<commit_message>
deck: add anticipated-questions slides to defend every plot
</commit_message>
<xml_diff>
--- a/marl_opp_aware_results.pptx
+++ b/marl_opp_aware_results.pptx
@@ -24,6 +24,8 @@
     <p:sldId id="272" r:id="rId24"/>
     <p:sldId id="273" r:id="rId25"/>
     <p:sldId id="274" r:id="rId26"/>
+    <p:sldId id="275" r:id="rId27"/>
+    <p:sldId id="276" r:id="rId28"/>
   </p:sldIdLst>
   <p:sldSz cx="12191695" cy="6858000" type="screen4x3"/>
   <p:notesSz cx="6858000" cy="9144000"/>
@@ -1220,7 +1222,7 @@
           <a:lstStyle/>
           <a:p>
             <a:r>
-              <a:t>Close on specific work. The repo has code hygiene, tests, result checks, and this deck. The scientific gap is the next experiment set: the oracle planner ceiling, a switching prey to test belief tracking, the HOP baseline, a genuinely distinct placement (snake path), and archived raw runs pinned to a release DOI. End with the concrete ask: accept the controlled result, fund the baseline and switching-opponent runs.</a:t>
+              <a:t>Anticipated questions — answer crisply, then stop. These are the sharpest ones the plots invite; each answer concedes what's honest and states the claim precisely. Full set with figures on the /present page's Figure guide.</a:t>
             </a:r>
           </a:p>
         </p:txBody>
@@ -1291,6 +1293,146 @@
           <a:p>
             <a:r>
               <a:t>Use this slide to state the exact claim. The evidence is captures per episode, not action accuracy. 4.31 is the main positive result. 1.42 explains why hard labels can hurt control. 4.08 shows the belief survives removing intent labels.</a:t>
+            </a:r>
+          </a:p>
+        </p:txBody>
+      </p:sp>
+      <p:sp>
+        <p:nvSpPr>
+          <p:cNvPr id="4" name="Slide Number Placeholder 3"/>
+          <p:cNvSpPr>
+            <a:spLocks noGrp="1"/>
+          </p:cNvSpPr>
+          <p:nvPr>
+            <p:ph type="sldNum" idx="5" sz="quarter"/>
+          </p:nvPr>
+        </p:nvSpPr>
+        <p:spPr/>
+      </p:sp>
+    </p:spTree>
+  </p:cSld>
+  <p:clrMapOvr>
+    <a:masterClrMapping/>
+  </p:clrMapOvr>
+</p:notes>
+</file>
+
+<file path=ppt/notesSlides/notesSlide20.xml><?xml version="1.0" encoding="utf-8"?>
+<p:notes xmlns:a="http://schemas.openxmlformats.org/drawingml/2006/main" xmlns:p="http://schemas.openxmlformats.org/presentationml/2006/main" xmlns:r="http://schemas.openxmlformats.org/officeDocument/2006/relationships">
+  <p:cSld>
+    <p:spTree>
+      <p:nvGrpSpPr>
+        <p:cNvPr id="1" name=""/>
+        <p:cNvGrpSpPr/>
+        <p:nvPr/>
+      </p:nvGrpSpPr>
+      <p:grpSpPr>
+        <a:xfrm>
+          <a:off x="0" y="0"/>
+          <a:ext cx="0" cy="0"/>
+          <a:chOff x="0" y="0"/>
+          <a:chExt cx="0" cy="0"/>
+        </a:xfrm>
+      </p:grpSpPr>
+      <p:sp>
+        <p:nvSpPr>
+          <p:cNvPr id="2" name="Slide Image Placeholder 1"/>
+          <p:cNvSpPr>
+            <a:spLocks noGrp="1"/>
+          </p:cNvSpPr>
+          <p:nvPr>
+            <p:ph type="sldImg" idx="2"/>
+          </p:nvPr>
+        </p:nvSpPr>
+        <p:spPr/>
+      </p:sp>
+      <p:sp>
+        <p:nvSpPr>
+          <p:cNvPr id="3" name="Notes Placeholder 2"/>
+          <p:cNvSpPr>
+            <a:spLocks noGrp="1"/>
+          </p:cNvSpPr>
+          <p:nvPr>
+            <p:ph type="body" idx="3" sz="quarter"/>
+          </p:nvPr>
+        </p:nvSpPr>
+        <p:spPr/>
+        <p:txBody>
+          <a:bodyPr/>
+          <a:lstStyle/>
+          <a:p>
+            <a:r>
+              <a:t>Anticipated questions — answer crisply, then stop. These are the sharpest ones the plots invite; each answer concedes what's honest and states the claim precisely. Full set with figures on the /present page's Figure guide.</a:t>
+            </a:r>
+          </a:p>
+        </p:txBody>
+      </p:sp>
+      <p:sp>
+        <p:nvSpPr>
+          <p:cNvPr id="4" name="Slide Number Placeholder 3"/>
+          <p:cNvSpPr>
+            <a:spLocks noGrp="1"/>
+          </p:cNvSpPr>
+          <p:nvPr>
+            <p:ph type="sldNum" idx="5" sz="quarter"/>
+          </p:nvPr>
+        </p:nvSpPr>
+        <p:spPr/>
+      </p:sp>
+    </p:spTree>
+  </p:cSld>
+  <p:clrMapOvr>
+    <a:masterClrMapping/>
+  </p:clrMapOvr>
+</p:notes>
+</file>
+
+<file path=ppt/notesSlides/notesSlide21.xml><?xml version="1.0" encoding="utf-8"?>
+<p:notes xmlns:a="http://schemas.openxmlformats.org/drawingml/2006/main" xmlns:p="http://schemas.openxmlformats.org/presentationml/2006/main" xmlns:r="http://schemas.openxmlformats.org/officeDocument/2006/relationships">
+  <p:cSld>
+    <p:spTree>
+      <p:nvGrpSpPr>
+        <p:cNvPr id="1" name=""/>
+        <p:cNvGrpSpPr/>
+        <p:nvPr/>
+      </p:nvGrpSpPr>
+      <p:grpSpPr>
+        <a:xfrm>
+          <a:off x="0" y="0"/>
+          <a:ext cx="0" cy="0"/>
+          <a:chOff x="0" y="0"/>
+          <a:chExt cx="0" cy="0"/>
+        </a:xfrm>
+      </p:grpSpPr>
+      <p:sp>
+        <p:nvSpPr>
+          <p:cNvPr id="2" name="Slide Image Placeholder 1"/>
+          <p:cNvSpPr>
+            <a:spLocks noGrp="1"/>
+          </p:cNvSpPr>
+          <p:nvPr>
+            <p:ph type="sldImg" idx="2"/>
+          </p:nvPr>
+        </p:nvSpPr>
+        <p:spPr/>
+      </p:sp>
+      <p:sp>
+        <p:nvSpPr>
+          <p:cNvPr id="3" name="Notes Placeholder 2"/>
+          <p:cNvSpPr>
+            <a:spLocks noGrp="1"/>
+          </p:cNvSpPr>
+          <p:nvPr>
+            <p:ph type="body" idx="3" sz="quarter"/>
+          </p:nvPr>
+        </p:nvSpPr>
+        <p:spPr/>
+        <p:txBody>
+          <a:bodyPr/>
+          <a:lstStyle/>
+          <a:p>
+            <a:r>
+              <a:t>Close on specific work. The repo has code hygiene, tests, result checks, and this deck. The scientific gap is the next experiment set: the oracle planner ceiling, a switching prey to test belief tracking, the HOP baseline, a genuinely distinct placement (snake path), and archived raw runs pinned to a release DOI. End with the concrete ask: accept the controlled result, fund the baseline and switching-opponent runs.</a:t>
             </a:r>
           </a:p>
         </p:txBody>
@@ -7142,7 +7284,7 @@
               </a:defRPr>
             </a:pPr>
             <a:r>
-              <a:t>CLOSE</a:t>
+              <a:t>DEFENSE</a:t>
             </a:r>
           </a:p>
         </p:txBody>
@@ -7177,7 +7319,7 @@
               </a:defRPr>
             </a:pPr>
             <a:r>
-              <a:t>Before submission, run the missing tests</a:t>
+              <a:t>Questions they'll ask</a:t>
             </a:r>
           </a:p>
         </p:txBody>
@@ -7190,29 +7332,29 @@
         </p:nvSpPr>
         <p:spPr>
           <a:xfrm>
-            <a:off x="822960" y="1554480"/>
-            <a:ext cx="2834640" cy="411480"/>
-          </a:xfrm>
-          <a:prstGeom prst="rect">
-            <a:avLst/>
-          </a:prstGeom>
-          <a:noFill/>
-        </p:spPr>
-        <p:txBody>
-          <a:bodyPr wrap="square">
-            <a:spAutoFit/>
-          </a:bodyPr>
-          <a:lstStyle/>
-          <a:p>
-            <a:pPr>
-              <a:defRPr sz="1800" b="1">
-                <a:solidFill>
-                  <a:srgbClr val="171717"/>
-                </a:solidFill>
-              </a:defRPr>
-            </a:pPr>
-            <a:r>
-              <a:t>Oracle planner</a:t>
+            <a:off x="640080" y="1417320"/>
+            <a:ext cx="10972800" cy="457200"/>
+          </a:xfrm>
+          <a:prstGeom prst="rect">
+            <a:avLst/>
+          </a:prstGeom>
+          <a:noFill/>
+        </p:spPr>
+        <p:txBody>
+          <a:bodyPr wrap="square">
+            <a:spAutoFit/>
+          </a:bodyPr>
+          <a:lstStyle/>
+          <a:p>
+            <a:pPr>
+              <a:defRPr sz="1600" b="1">
+                <a:solidFill>
+                  <a:srgbClr val="0D6E7A"/>
+                </a:solidFill>
+              </a:defRPr>
+            </a:pPr>
+            <a:r>
+              <a:t>Q  Beating the oracle looks too good — is it real?</a:t>
             </a:r>
           </a:p>
         </p:txBody>
@@ -7225,29 +7367,29 @@
         </p:nvSpPr>
         <p:spPr>
           <a:xfrm>
-            <a:off x="3840480" y="1554480"/>
-            <a:ext cx="7680960" cy="502920"/>
-          </a:xfrm>
-          <a:prstGeom prst="rect">
-            <a:avLst/>
-          </a:prstGeom>
-          <a:noFill/>
-        </p:spPr>
-        <p:txBody>
-          <a:bodyPr wrap="square">
-            <a:spAutoFit/>
-          </a:bodyPr>
-          <a:lstStyle/>
-          <a:p>
-            <a:pPr>
-              <a:defRPr sz="1700" b="0">
+            <a:off x="640080" y="1874519"/>
+            <a:ext cx="10972800" cy="731520"/>
+          </a:xfrm>
+          <a:prstGeom prst="rect">
+            <a:avLst/>
+          </a:prstGeom>
+          <a:noFill/>
+        </p:spPr>
+        <p:txBody>
+          <a:bodyPr wrap="square">
+            <a:spAutoFit/>
+          </a:bodyPr>
+          <a:lstStyle/>
+          <a:p>
+            <a:pPr>
+              <a:defRPr sz="1400" b="0">
                 <a:solidFill>
                   <a:srgbClr val="4A4A4A"/>
                 </a:solidFill>
               </a:defRPr>
             </a:pPr>
             <a:r>
-              <a:t>Measures the true planning ceiling with known intent.</a:t>
+              <a:t>A  It exceeds a REACTIVE oracle (true intent, no lookahead). Planning pre-positions, so 4.31 &gt; 4.05. An oracle PLANNER is the true ceiling, and it's on the to-run list.</a:t>
             </a:r>
           </a:p>
         </p:txBody>
@@ -7260,29 +7402,29 @@
         </p:nvSpPr>
         <p:spPr>
           <a:xfrm>
-            <a:off x="822960" y="2267712"/>
-            <a:ext cx="2834640" cy="411480"/>
-          </a:xfrm>
-          <a:prstGeom prst="rect">
-            <a:avLst/>
-          </a:prstGeom>
-          <a:noFill/>
-        </p:spPr>
-        <p:txBody>
-          <a:bodyPr wrap="square">
-            <a:spAutoFit/>
-          </a:bodyPr>
-          <a:lstStyle/>
-          <a:p>
-            <a:pPr>
-              <a:defRPr sz="1800" b="1">
-                <a:solidFill>
-                  <a:srgbClr val="171717"/>
-                </a:solidFill>
-              </a:defRPr>
-            </a:pPr>
-            <a:r>
-              <a:t>Switching prey</a:t>
+            <a:off x="640080" y="2715768"/>
+            <a:ext cx="10972800" cy="457200"/>
+          </a:xfrm>
+          <a:prstGeom prst="rect">
+            <a:avLst/>
+          </a:prstGeom>
+          <a:noFill/>
+        </p:spPr>
+        <p:txBody>
+          <a:bodyPr wrap="square">
+            <a:spAutoFit/>
+          </a:bodyPr>
+          <a:lstStyle/>
+          <a:p>
+            <a:pPr>
+              <a:defRPr sz="1600" b="1">
+                <a:solidFill>
+                  <a:srgbClr val="0D6E7A"/>
+                </a:solidFill>
+              </a:defRPr>
+            </a:pPr>
+            <a:r>
+              <a:t>Q  Why does an honestly inferred hard intent (2.56) lose to blind (2.68)?</a:t>
             </a:r>
           </a:p>
         </p:txBody>
@@ -7295,29 +7437,29 @@
         </p:nvSpPr>
         <p:spPr>
           <a:xfrm>
-            <a:off x="3840480" y="2267712"/>
-            <a:ext cx="7680960" cy="502920"/>
-          </a:xfrm>
-          <a:prstGeom prst="rect">
-            <a:avLst/>
-          </a:prstGeom>
-          <a:noFill/>
-        </p:spPr>
-        <p:txBody>
-          <a:bodyPr wrap="square">
-            <a:spAutoFit/>
-          </a:bodyPr>
-          <a:lstStyle/>
-          <a:p>
-            <a:pPr>
-              <a:defRPr sz="1700" b="0">
+            <a:off x="640080" y="3172968"/>
+            <a:ext cx="10972800" cy="731520"/>
+          </a:xfrm>
+          <a:prstGeom prst="rect">
+            <a:avLst/>
+          </a:prstGeom>
+          <a:noFill/>
+        </p:spPr>
+        <p:txBody>
+          <a:bodyPr wrap="square">
+            <a:spAutoFit/>
+          </a:bodyPr>
+          <a:lstStyle/>
+          <a:p>
+            <a:pPr>
+              <a:defRPr sz="1400" b="0">
                 <a:solidFill>
                   <a:srgbClr val="4A4A4A"/>
                 </a:solidFill>
               </a:defRPr>
             </a:pPr>
             <a:r>
-              <a:t>Tests whether the belief tracks a strategy change mid-episode.</a:t>
+              <a:t>A  The argmax at k=8 is ~74% accurate; committing to a wrong corner costs more than hedging. That's the whole case for carrying the distribution, not a point estimate.</a:t>
             </a:r>
           </a:p>
         </p:txBody>
@@ -7330,29 +7472,29 @@
         </p:nvSpPr>
         <p:spPr>
           <a:xfrm>
-            <a:off x="822960" y="2980944"/>
-            <a:ext cx="2834640" cy="411480"/>
-          </a:xfrm>
-          <a:prstGeom prst="rect">
-            <a:avLst/>
-          </a:prstGeom>
-          <a:noFill/>
-        </p:spPr>
-        <p:txBody>
-          <a:bodyPr wrap="square">
-            <a:spAutoFit/>
-          </a:bodyPr>
-          <a:lstStyle/>
-          <a:p>
-            <a:pPr>
-              <a:defRPr sz="1800" b="1">
-                <a:solidFill>
-                  <a:srgbClr val="171717"/>
-                </a:solidFill>
-              </a:defRPr>
-            </a:pPr>
-            <a:r>
-              <a:t>HOP baseline</a:t>
+            <a:off x="640080" y="4014215"/>
+            <a:ext cx="10972800" cy="457200"/>
+          </a:xfrm>
+          <a:prstGeom prst="rect">
+            <a:avLst/>
+          </a:prstGeom>
+          <a:noFill/>
+        </p:spPr>
+        <p:txBody>
+          <a:bodyPr wrap="square">
+            <a:spAutoFit/>
+          </a:bodyPr>
+          <a:lstStyle/>
+          <a:p>
+            <a:pPr>
+              <a:defRPr sz="1600" b="1">
+                <a:solidFill>
+                  <a:srgbClr val="0D6E7A"/>
+                </a:solidFill>
+              </a:defRPr>
+            </a:pPr>
+            <a:r>
+              <a:t>Q  Probe vs ARI — what's the difference?</a:t>
             </a:r>
           </a:p>
         </p:txBody>
@@ -7365,29 +7507,29 @@
         </p:nvSpPr>
         <p:spPr>
           <a:xfrm>
-            <a:off x="3840480" y="2980944"/>
-            <a:ext cx="7680960" cy="502920"/>
-          </a:xfrm>
-          <a:prstGeom prst="rect">
-            <a:avLst/>
-          </a:prstGeom>
-          <a:noFill/>
-        </p:spPr>
-        <p:txBody>
-          <a:bodyPr wrap="square">
-            <a:spAutoFit/>
-          </a:bodyPr>
-          <a:lstStyle/>
-          <a:p>
-            <a:pPr>
-              <a:defRPr sz="1700" b="0">
+            <a:off x="640080" y="4471416"/>
+            <a:ext cx="10972800" cy="731520"/>
+          </a:xfrm>
+          <a:prstGeom prst="rect">
+            <a:avLst/>
+          </a:prstGeom>
+          <a:noFill/>
+        </p:spPr>
+        <p:txBody>
+          <a:bodyPr wrap="square">
+            <a:spAutoFit/>
+          </a:bodyPr>
+          <a:lstStyle/>
+          <a:p>
+            <a:pPr>
+              <a:defRPr sz="1400" b="0">
                 <a:solidFill>
                   <a:srgbClr val="4A4A4A"/>
                 </a:solidFill>
               </a:defRPr>
             </a:pPr>
             <a:r>
-              <a:t>Checks the closest belief-search comparator.</a:t>
+              <a:t>A  Probe = can a LINEAR readout with labels decode the latent (chance 0.25). ARI = does it cluster WITHOUT labels. On intent both are high; on circle-vs-corners only the probe is.</a:t>
             </a:r>
           </a:p>
         </p:txBody>
@@ -7400,29 +7542,29 @@
         </p:nvSpPr>
         <p:spPr>
           <a:xfrm>
-            <a:off x="822960" y="3694176"/>
-            <a:ext cx="2834640" cy="411480"/>
-          </a:xfrm>
-          <a:prstGeom prst="rect">
-            <a:avLst/>
-          </a:prstGeom>
-          <a:noFill/>
-        </p:spPr>
-        <p:txBody>
-          <a:bodyPr wrap="square">
-            <a:spAutoFit/>
-          </a:bodyPr>
-          <a:lstStyle/>
-          <a:p>
-            <a:pPr>
-              <a:defRPr sz="1800" b="1">
-                <a:solidFill>
-                  <a:srgbClr val="171717"/>
-                </a:solidFill>
-              </a:defRPr>
-            </a:pPr>
-            <a:r>
-              <a:t>Snake placement</a:t>
+            <a:off x="640080" y="5312664"/>
+            <a:ext cx="10972800" cy="457200"/>
+          </a:xfrm>
+          <a:prstGeom prst="rect">
+            <a:avLst/>
+          </a:prstGeom>
+          <a:noFill/>
+        </p:spPr>
+        <p:txBody>
+          <a:bodyPr wrap="square">
+            <a:spAutoFit/>
+          </a:bodyPr>
+          <a:lstStyle/>
+          <a:p>
+            <a:pPr>
+              <a:defRPr sz="1600" b="1">
+                <a:solidFill>
+                  <a:srgbClr val="0D6E7A"/>
+                </a:solidFill>
+              </a:defRPr>
+            </a:pPr>
+            <a:r>
+              <a:t>Q  Isn't JEPA just a better-tuned VAE?</a:t>
             </a:r>
           </a:p>
         </p:txBody>
@@ -7435,134 +7577,29 @@
         </p:nvSpPr>
         <p:spPr>
           <a:xfrm>
-            <a:off x="3840480" y="3694176"/>
-            <a:ext cx="7680960" cy="502920"/>
-          </a:xfrm>
-          <a:prstGeom prst="rect">
-            <a:avLst/>
-          </a:prstGeom>
-          <a:noFill/>
-        </p:spPr>
-        <p:txBody>
-          <a:bodyPr wrap="square">
-            <a:spAutoFit/>
-          </a:bodyPr>
-          <a:lstStyle/>
-          <a:p>
-            <a:pPr>
-              <a:defRPr sz="1700" b="0">
+            <a:off x="640080" y="5769864"/>
+            <a:ext cx="10972800" cy="731520"/>
+          </a:xfrm>
+          <a:prstGeom prst="rect">
+            <a:avLst/>
+          </a:prstGeom>
+          <a:noFill/>
+        </p:spPr>
+        <p:txBody>
+          <a:bodyPr wrap="square">
+            <a:spAutoFit/>
+          </a:bodyPr>
+          <a:lstStyle/>
+          <a:p>
+            <a:pPr>
+              <a:defRPr sz="1400" b="0">
                 <a:solidFill>
                   <a:srgbClr val="4A4A4A"/>
                 </a:solidFill>
               </a:defRPr>
             </a:pPr>
             <a:r>
-              <a:t>A genuinely distinct behaviour class, so clusters can exist.</a:t>
-            </a:r>
-          </a:p>
-        </p:txBody>
-      </p:sp>
-      <p:sp>
-        <p:nvSpPr>
-          <p:cNvPr id="13" name="TextBox 12"/>
-          <p:cNvSpPr txBox="1"/>
-          <p:nvPr/>
-        </p:nvSpPr>
-        <p:spPr>
-          <a:xfrm>
-            <a:off x="822960" y="4407408"/>
-            <a:ext cx="2834640" cy="411480"/>
-          </a:xfrm>
-          <a:prstGeom prst="rect">
-            <a:avLst/>
-          </a:prstGeom>
-          <a:noFill/>
-        </p:spPr>
-        <p:txBody>
-          <a:bodyPr wrap="square">
-            <a:spAutoFit/>
-          </a:bodyPr>
-          <a:lstStyle/>
-          <a:p>
-            <a:pPr>
-              <a:defRPr sz="1800" b="1">
-                <a:solidFill>
-                  <a:srgbClr val="171717"/>
-                </a:solidFill>
-              </a:defRPr>
-            </a:pPr>
-            <a:r>
-              <a:t>Raw artifact archive</a:t>
-            </a:r>
-          </a:p>
-        </p:txBody>
-      </p:sp>
-      <p:sp>
-        <p:nvSpPr>
-          <p:cNvPr id="14" name="TextBox 13"/>
-          <p:cNvSpPr txBox="1"/>
-          <p:nvPr/>
-        </p:nvSpPr>
-        <p:spPr>
-          <a:xfrm>
-            <a:off x="3840480" y="4407408"/>
-            <a:ext cx="7680960" cy="502920"/>
-          </a:xfrm>
-          <a:prstGeom prst="rect">
-            <a:avLst/>
-          </a:prstGeom>
-          <a:noFill/>
-        </p:spPr>
-        <p:txBody>
-          <a:bodyPr wrap="square">
-            <a:spAutoFit/>
-          </a:bodyPr>
-          <a:lstStyle/>
-          <a:p>
-            <a:pPr>
-              <a:defRPr sz="1700" b="0">
-                <a:solidFill>
-                  <a:srgbClr val="4A4A4A"/>
-                </a:solidFill>
-              </a:defRPr>
-            </a:pPr>
-            <a:r>
-              <a:t>Pins checkpoints, logs, and metrics to a release DOI.</a:t>
-            </a:r>
-          </a:p>
-        </p:txBody>
-      </p:sp>
-      <p:sp>
-        <p:nvSpPr>
-          <p:cNvPr id="15" name="TextBox 14"/>
-          <p:cNvSpPr txBox="1"/>
-          <p:nvPr/>
-        </p:nvSpPr>
-        <p:spPr>
-          <a:xfrm>
-            <a:off x="822960" y="5349240"/>
-            <a:ext cx="10607040" cy="548640"/>
-          </a:xfrm>
-          <a:prstGeom prst="rect">
-            <a:avLst/>
-          </a:prstGeom>
-          <a:noFill/>
-        </p:spPr>
-        <p:txBody>
-          <a:bodyPr wrap="square">
-            <a:spAutoFit/>
-          </a:bodyPr>
-          <a:lstStyle/>
-          <a:p>
-            <a:pPr>
-              <a:defRPr sz="1800" b="1">
-                <a:solidFill>
-                  <a:srgbClr val="171717"/>
-                </a:solidFill>
-              </a:defRPr>
-            </a:pPr>
-            <a:r>
-              <a:t>End with a concrete ask: accept the controlled result, then fund the baseline and switching-opponent run.</a:t>
+              <a:t>A  Same data, latent size, and budget. JEPA predicts the future representation (no decoder); the VAE reconstructs. The gap (0.89 vs 0.53) is the objective, not the tuning.</a:t>
             </a:r>
           </a:p>
         </p:txBody>
@@ -7931,6 +7968,917 @@
             </a:pPr>
             <a:r>
               <a:t>captures/episode with the label-free JEPA belief</a:t>
+            </a:r>
+          </a:p>
+        </p:txBody>
+      </p:sp>
+    </p:spTree>
+  </p:cSld>
+  <p:clrMapOvr>
+    <a:masterClrMapping/>
+  </p:clrMapOvr>
+</p:sld>
+</file>
+
+<file path=ppt/slides/slide20.xml><?xml version="1.0" encoding="utf-8"?>
+<p:sld xmlns:a="http://schemas.openxmlformats.org/drawingml/2006/main" xmlns:p="http://schemas.openxmlformats.org/presentationml/2006/main" xmlns:r="http://schemas.openxmlformats.org/officeDocument/2006/relationships">
+  <p:cSld>
+    <p:spTree>
+      <p:nvGrpSpPr>
+        <p:cNvPr id="1" name=""/>
+        <p:cNvGrpSpPr/>
+        <p:nvPr/>
+      </p:nvGrpSpPr>
+      <p:grpSpPr/>
+      <p:sp>
+        <p:nvSpPr>
+          <p:cNvPr id="2" name="TextBox 1"/>
+          <p:cNvSpPr txBox="1"/>
+          <p:nvPr/>
+        </p:nvSpPr>
+        <p:spPr>
+          <a:xfrm>
+            <a:off x="11368735" y="6400800"/>
+            <a:ext cx="548640" cy="274320"/>
+          </a:xfrm>
+          <a:prstGeom prst="rect">
+            <a:avLst/>
+          </a:prstGeom>
+          <a:noFill/>
+        </p:spPr>
+        <p:txBody>
+          <a:bodyPr wrap="none">
+            <a:spAutoFit/>
+          </a:bodyPr>
+          <a:lstStyle/>
+          <a:p>
+            <a:pPr>
+              <a:defRPr sz="1100">
+                <a:solidFill>
+                  <a:srgbClr val="4A4A4A"/>
+                </a:solidFill>
+              </a:defRPr>
+            </a:pPr>
+            <a:r>
+              <a:t>20</a:t>
+            </a:r>
+          </a:p>
+        </p:txBody>
+      </p:sp>
+      <p:sp>
+        <p:nvSpPr>
+          <p:cNvPr id="3" name="TextBox 2"/>
+          <p:cNvSpPr txBox="1"/>
+          <p:nvPr/>
+        </p:nvSpPr>
+        <p:spPr>
+          <a:xfrm>
+            <a:off x="502920" y="256032"/>
+            <a:ext cx="3657600" cy="320040"/>
+          </a:xfrm>
+          <a:prstGeom prst="rect">
+            <a:avLst/>
+          </a:prstGeom>
+          <a:noFill/>
+        </p:spPr>
+        <p:txBody>
+          <a:bodyPr wrap="square">
+            <a:spAutoFit/>
+          </a:bodyPr>
+          <a:lstStyle/>
+          <a:p>
+            <a:pPr>
+              <a:defRPr sz="1200" b="1">
+                <a:solidFill>
+                  <a:srgbClr val="0D6E7A"/>
+                </a:solidFill>
+              </a:defRPr>
+            </a:pPr>
+            <a:r>
+              <a:t>DEFENSE</a:t>
+            </a:r>
+          </a:p>
+        </p:txBody>
+      </p:sp>
+      <p:sp>
+        <p:nvSpPr>
+          <p:cNvPr id="4" name="TextBox 3"/>
+          <p:cNvSpPr txBox="1"/>
+          <p:nvPr/>
+        </p:nvSpPr>
+        <p:spPr>
+          <a:xfrm>
+            <a:off x="502920" y="502920"/>
+            <a:ext cx="11185855" cy="822960"/>
+          </a:xfrm>
+          <a:prstGeom prst="rect">
+            <a:avLst/>
+          </a:prstGeom>
+          <a:noFill/>
+        </p:spPr>
+        <p:txBody>
+          <a:bodyPr wrap="square">
+            <a:spAutoFit/>
+          </a:bodyPr>
+          <a:lstStyle/>
+          <a:p>
+            <a:pPr>
+              <a:defRPr sz="2700" b="1">
+                <a:solidFill>
+                  <a:srgbClr val="171717"/>
+                </a:solidFill>
+              </a:defRPr>
+            </a:pPr>
+            <a:r>
+              <a:t>Questions they'll ask (cont.)</a:t>
+            </a:r>
+          </a:p>
+        </p:txBody>
+      </p:sp>
+      <p:sp>
+        <p:nvSpPr>
+          <p:cNvPr id="5" name="TextBox 4"/>
+          <p:cNvSpPr txBox="1"/>
+          <p:nvPr/>
+        </p:nvSpPr>
+        <p:spPr>
+          <a:xfrm>
+            <a:off x="640080" y="1417320"/>
+            <a:ext cx="10972800" cy="457200"/>
+          </a:xfrm>
+          <a:prstGeom prst="rect">
+            <a:avLst/>
+          </a:prstGeom>
+          <a:noFill/>
+        </p:spPr>
+        <p:txBody>
+          <a:bodyPr wrap="square">
+            <a:spAutoFit/>
+          </a:bodyPr>
+          <a:lstStyle/>
+          <a:p>
+            <a:pPr>
+              <a:defRPr sz="1600" b="1">
+                <a:solidFill>
+                  <a:srgbClr val="0D6E7A"/>
+                </a:solidFill>
+              </a:defRPr>
+            </a:pPr>
+            <a:r>
+              <a:t>Q  Aren't circles just squares? (the meeting challenge)</a:t>
+            </a:r>
+          </a:p>
+        </p:txBody>
+      </p:sp>
+      <p:sp>
+        <p:nvSpPr>
+          <p:cNvPr id="6" name="TextBox 5"/>
+          <p:cNvSpPr txBox="1"/>
+          <p:nvPr/>
+        </p:nvSpPr>
+        <p:spPr>
+          <a:xfrm>
+            <a:off x="640080" y="1874519"/>
+            <a:ext cx="10972800" cy="731520"/>
+          </a:xfrm>
+          <a:prstGeom prst="rect">
+            <a:avLst/>
+          </a:prstGeom>
+          <a:noFill/>
+        </p:spPr>
+        <p:txBody>
+          <a:bodyPr wrap="square">
+            <a:spAutoFit/>
+          </a:bodyPr>
+          <a:lstStyle/>
+          <a:p>
+            <a:pPr>
+              <a:defRPr sz="1400" b="0">
+                <a:solidFill>
+                  <a:srgbClr val="4A4A4A"/>
+                </a:solidFill>
+              </a:defRPr>
+            </a:pPr>
+            <a:r>
+              <a:t>A  Geometrically yes — 4 points on a circle are a small square. Behaviourally no: corners commit to 4 sharp spots, the circle smears a diffuse ring (cosine 0.42). The circle signal is just weak.</a:t>
+            </a:r>
+          </a:p>
+        </p:txBody>
+      </p:sp>
+      <p:sp>
+        <p:nvSpPr>
+          <p:cNvPr id="7" name="TextBox 6"/>
+          <p:cNvSpPr txBox="1"/>
+          <p:nvPr/>
+        </p:nvSpPr>
+        <p:spPr>
+          <a:xfrm>
+            <a:off x="640080" y="2715768"/>
+            <a:ext cx="10972800" cy="457200"/>
+          </a:xfrm>
+          <a:prstGeom prst="rect">
+            <a:avLst/>
+          </a:prstGeom>
+          <a:noFill/>
+        </p:spPr>
+        <p:txBody>
+          <a:bodyPr wrap="square">
+            <a:spAutoFit/>
+          </a:bodyPr>
+          <a:lstStyle/>
+          <a:p>
+            <a:pPr>
+              <a:defRPr sz="1600" b="1">
+                <a:solidFill>
+                  <a:srgbClr val="0D6E7A"/>
+                </a:solidFill>
+              </a:defRPr>
+            </a:pPr>
+            <a:r>
+              <a:t>Q  If it's decodable (0.93), why doesn't it cluster (ARI≈0)?</a:t>
+            </a:r>
+          </a:p>
+        </p:txBody>
+      </p:sp>
+      <p:sp>
+        <p:nvSpPr>
+          <p:cNvPr id="8" name="TextBox 7"/>
+          <p:cNvSpPr txBox="1"/>
+          <p:nvPr/>
+        </p:nvSpPr>
+        <p:spPr>
+          <a:xfrm>
+            <a:off x="640080" y="3172968"/>
+            <a:ext cx="10972800" cy="731520"/>
+          </a:xfrm>
+          <a:prstGeom prst="rect">
+            <a:avLst/>
+          </a:prstGeom>
+          <a:noFill/>
+        </p:spPr>
+        <p:txBody>
+          <a:bodyPr wrap="square">
+            <a:spAutoFit/>
+          </a:bodyPr>
+          <a:lstStyle/>
+          <a:p>
+            <a:pPr>
+              <a:defRPr sz="1400" b="0">
+                <a:solidFill>
+                  <a:srgbClr val="4A4A4A"/>
+                </a:solidFill>
+              </a:defRPr>
+            </a:pPr>
+            <a:r>
+              <a:t>A  Linear separability ≠ two modes. The placement is a DIRECTION in latent space, not two blobs. Shaping it to cluster (contrastive / equivariant) is the open problem.</a:t>
+            </a:r>
+          </a:p>
+        </p:txBody>
+      </p:sp>
+      <p:sp>
+        <p:nvSpPr>
+          <p:cNvPr id="9" name="TextBox 8"/>
+          <p:cNvSpPr txBox="1"/>
+          <p:nvPr/>
+        </p:nvSpPr>
+        <p:spPr>
+          <a:xfrm>
+            <a:off x="640080" y="4014215"/>
+            <a:ext cx="10972800" cy="457200"/>
+          </a:xfrm>
+          <a:prstGeom prst="rect">
+            <a:avLst/>
+          </a:prstGeom>
+          <a:noFill/>
+        </p:spPr>
+        <p:txBody>
+          <a:bodyPr wrap="square">
+            <a:spAutoFit/>
+          </a:bodyPr>
+          <a:lstStyle/>
+          <a:p>
+            <a:pPr>
+              <a:defRPr sz="1600" b="1">
+                <a:solidFill>
+                  <a:srgbClr val="0D6E7A"/>
+                </a:solidFill>
+              </a:defRPr>
+            </a:pPr>
+            <a:r>
+              <a:t>Q  Is the latent-BC sweep gain just averaging over more episodes?</a:t>
+            </a:r>
+          </a:p>
+        </p:txBody>
+      </p:sp>
+      <p:sp>
+        <p:nvSpPr>
+          <p:cNvPr id="10" name="TextBox 9"/>
+          <p:cNvSpPr txBox="1"/>
+          <p:nvPr/>
+        </p:nvSpPr>
+        <p:spPr>
+          <a:xfrm>
+            <a:off x="640080" y="4471416"/>
+            <a:ext cx="10972800" cy="731520"/>
+          </a:xfrm>
+          <a:prstGeom prst="rect">
+            <a:avLst/>
+          </a:prstGeom>
+          <a:noFill/>
+        </p:spPr>
+        <p:txBody>
+          <a:bodyPr wrap="square">
+            <a:spAutoFit/>
+          </a:bodyPr>
+          <a:lstStyle/>
+          <a:p>
+            <a:pPr>
+              <a:defRPr sz="1400" b="0">
+                <a:solidFill>
+                  <a:srgbClr val="4A4A4A"/>
+                </a:solidFill>
+              </a:defRPr>
+            </a:pPr>
+            <a:r>
+              <a:t>A  Largely yes, and I say so: the placement is FIXED, so longer observation is a better occupancy ESTIMATE, not a strategy unfolding. It's a scaling-with-observation result.</a:t>
+            </a:r>
+          </a:p>
+        </p:txBody>
+      </p:sp>
+      <p:sp>
+        <p:nvSpPr>
+          <p:cNvPr id="11" name="TextBox 10"/>
+          <p:cNvSpPr txBox="1"/>
+          <p:nvPr/>
+        </p:nvSpPr>
+        <p:spPr>
+          <a:xfrm>
+            <a:off x="640080" y="5312664"/>
+            <a:ext cx="10972800" cy="457200"/>
+          </a:xfrm>
+          <a:prstGeom prst="rect">
+            <a:avLst/>
+          </a:prstGeom>
+          <a:noFill/>
+        </p:spPr>
+        <p:txBody>
+          <a:bodyPr wrap="square">
+            <a:spAutoFit/>
+          </a:bodyPr>
+          <a:lstStyle/>
+          <a:p>
+            <a:pPr>
+              <a:defRPr sz="1600" b="1">
+                <a:solidFill>
+                  <a:srgbClr val="0D6E7A"/>
+                </a:solidFill>
+              </a:defRPr>
+            </a:pPr>
+            <a:r>
+              <a:t>Q  The BC-failure GIF — cherry-picked?</a:t>
+            </a:r>
+          </a:p>
+        </p:txBody>
+      </p:sp>
+      <p:sp>
+        <p:nvSpPr>
+          <p:cNvPr id="12" name="TextBox 11"/>
+          <p:cNvSpPr txBox="1"/>
+          <p:nvPr/>
+        </p:nvSpPr>
+        <p:spPr>
+          <a:xfrm>
+            <a:off x="640080" y="5769864"/>
+            <a:ext cx="10972800" cy="731520"/>
+          </a:xfrm>
+          <a:prstGeom prst="rect">
+            <a:avLst/>
+          </a:prstGeom>
+          <a:noFill/>
+        </p:spPr>
+        <p:txBody>
+          <a:bodyPr wrap="square">
+            <a:spAutoFit/>
+          </a:bodyPr>
+          <a:lstStyle/>
+          <a:p>
+            <a:pPr>
+              <a:defRPr sz="1400" b="0">
+                <a:solidFill>
+                  <a:srgbClr val="4A4A4A"/>
+                </a:solidFill>
+              </a:defRPr>
+            </a:pPr>
+            <a:r>
+              <a:t>A  Deliberately: tail episodes chosen to show the mechanism. The average is the table (86% recovery, +2.4 accuracy pts). The GIF explains WHY, the table is the claim.</a:t>
+            </a:r>
+          </a:p>
+        </p:txBody>
+      </p:sp>
+    </p:spTree>
+  </p:cSld>
+  <p:clrMapOvr>
+    <a:masterClrMapping/>
+  </p:clrMapOvr>
+</p:sld>
+</file>
+
+<file path=ppt/slides/slide21.xml><?xml version="1.0" encoding="utf-8"?>
+<p:sld xmlns:a="http://schemas.openxmlformats.org/drawingml/2006/main" xmlns:p="http://schemas.openxmlformats.org/presentationml/2006/main" xmlns:r="http://schemas.openxmlformats.org/officeDocument/2006/relationships">
+  <p:cSld>
+    <p:spTree>
+      <p:nvGrpSpPr>
+        <p:cNvPr id="1" name=""/>
+        <p:cNvGrpSpPr/>
+        <p:nvPr/>
+      </p:nvGrpSpPr>
+      <p:grpSpPr/>
+      <p:sp>
+        <p:nvSpPr>
+          <p:cNvPr id="2" name="TextBox 1"/>
+          <p:cNvSpPr txBox="1"/>
+          <p:nvPr/>
+        </p:nvSpPr>
+        <p:spPr>
+          <a:xfrm>
+            <a:off x="11368735" y="6400800"/>
+            <a:ext cx="548640" cy="274320"/>
+          </a:xfrm>
+          <a:prstGeom prst="rect">
+            <a:avLst/>
+          </a:prstGeom>
+          <a:noFill/>
+        </p:spPr>
+        <p:txBody>
+          <a:bodyPr wrap="none">
+            <a:spAutoFit/>
+          </a:bodyPr>
+          <a:lstStyle/>
+          <a:p>
+            <a:pPr>
+              <a:defRPr sz="1100">
+                <a:solidFill>
+                  <a:srgbClr val="4A4A4A"/>
+                </a:solidFill>
+              </a:defRPr>
+            </a:pPr>
+            <a:r>
+              <a:t>21</a:t>
+            </a:r>
+          </a:p>
+        </p:txBody>
+      </p:sp>
+      <p:sp>
+        <p:nvSpPr>
+          <p:cNvPr id="3" name="TextBox 2"/>
+          <p:cNvSpPr txBox="1"/>
+          <p:nvPr/>
+        </p:nvSpPr>
+        <p:spPr>
+          <a:xfrm>
+            <a:off x="502920" y="256032"/>
+            <a:ext cx="3657600" cy="320040"/>
+          </a:xfrm>
+          <a:prstGeom prst="rect">
+            <a:avLst/>
+          </a:prstGeom>
+          <a:noFill/>
+        </p:spPr>
+        <p:txBody>
+          <a:bodyPr wrap="square">
+            <a:spAutoFit/>
+          </a:bodyPr>
+          <a:lstStyle/>
+          <a:p>
+            <a:pPr>
+              <a:defRPr sz="1200" b="1">
+                <a:solidFill>
+                  <a:srgbClr val="0D6E7A"/>
+                </a:solidFill>
+              </a:defRPr>
+            </a:pPr>
+            <a:r>
+              <a:t>CLOSE</a:t>
+            </a:r>
+          </a:p>
+        </p:txBody>
+      </p:sp>
+      <p:sp>
+        <p:nvSpPr>
+          <p:cNvPr id="4" name="TextBox 3"/>
+          <p:cNvSpPr txBox="1"/>
+          <p:nvPr/>
+        </p:nvSpPr>
+        <p:spPr>
+          <a:xfrm>
+            <a:off x="502920" y="502920"/>
+            <a:ext cx="11185855" cy="822960"/>
+          </a:xfrm>
+          <a:prstGeom prst="rect">
+            <a:avLst/>
+          </a:prstGeom>
+          <a:noFill/>
+        </p:spPr>
+        <p:txBody>
+          <a:bodyPr wrap="square">
+            <a:spAutoFit/>
+          </a:bodyPr>
+          <a:lstStyle/>
+          <a:p>
+            <a:pPr>
+              <a:defRPr sz="2700" b="1">
+                <a:solidFill>
+                  <a:srgbClr val="171717"/>
+                </a:solidFill>
+              </a:defRPr>
+            </a:pPr>
+            <a:r>
+              <a:t>Before submission, run the missing tests</a:t>
+            </a:r>
+          </a:p>
+        </p:txBody>
+      </p:sp>
+      <p:sp>
+        <p:nvSpPr>
+          <p:cNvPr id="5" name="TextBox 4"/>
+          <p:cNvSpPr txBox="1"/>
+          <p:nvPr/>
+        </p:nvSpPr>
+        <p:spPr>
+          <a:xfrm>
+            <a:off x="822960" y="1554480"/>
+            <a:ext cx="2834640" cy="411480"/>
+          </a:xfrm>
+          <a:prstGeom prst="rect">
+            <a:avLst/>
+          </a:prstGeom>
+          <a:noFill/>
+        </p:spPr>
+        <p:txBody>
+          <a:bodyPr wrap="square">
+            <a:spAutoFit/>
+          </a:bodyPr>
+          <a:lstStyle/>
+          <a:p>
+            <a:pPr>
+              <a:defRPr sz="1800" b="1">
+                <a:solidFill>
+                  <a:srgbClr val="171717"/>
+                </a:solidFill>
+              </a:defRPr>
+            </a:pPr>
+            <a:r>
+              <a:t>Oracle planner</a:t>
+            </a:r>
+          </a:p>
+        </p:txBody>
+      </p:sp>
+      <p:sp>
+        <p:nvSpPr>
+          <p:cNvPr id="6" name="TextBox 5"/>
+          <p:cNvSpPr txBox="1"/>
+          <p:nvPr/>
+        </p:nvSpPr>
+        <p:spPr>
+          <a:xfrm>
+            <a:off x="3840480" y="1554480"/>
+            <a:ext cx="7680960" cy="502920"/>
+          </a:xfrm>
+          <a:prstGeom prst="rect">
+            <a:avLst/>
+          </a:prstGeom>
+          <a:noFill/>
+        </p:spPr>
+        <p:txBody>
+          <a:bodyPr wrap="square">
+            <a:spAutoFit/>
+          </a:bodyPr>
+          <a:lstStyle/>
+          <a:p>
+            <a:pPr>
+              <a:defRPr sz="1700" b="0">
+                <a:solidFill>
+                  <a:srgbClr val="4A4A4A"/>
+                </a:solidFill>
+              </a:defRPr>
+            </a:pPr>
+            <a:r>
+              <a:t>Measures the true planning ceiling with known intent.</a:t>
+            </a:r>
+          </a:p>
+        </p:txBody>
+      </p:sp>
+      <p:sp>
+        <p:nvSpPr>
+          <p:cNvPr id="7" name="TextBox 6"/>
+          <p:cNvSpPr txBox="1"/>
+          <p:nvPr/>
+        </p:nvSpPr>
+        <p:spPr>
+          <a:xfrm>
+            <a:off x="822960" y="2267712"/>
+            <a:ext cx="2834640" cy="411480"/>
+          </a:xfrm>
+          <a:prstGeom prst="rect">
+            <a:avLst/>
+          </a:prstGeom>
+          <a:noFill/>
+        </p:spPr>
+        <p:txBody>
+          <a:bodyPr wrap="square">
+            <a:spAutoFit/>
+          </a:bodyPr>
+          <a:lstStyle/>
+          <a:p>
+            <a:pPr>
+              <a:defRPr sz="1800" b="1">
+                <a:solidFill>
+                  <a:srgbClr val="171717"/>
+                </a:solidFill>
+              </a:defRPr>
+            </a:pPr>
+            <a:r>
+              <a:t>Switching prey</a:t>
+            </a:r>
+          </a:p>
+        </p:txBody>
+      </p:sp>
+      <p:sp>
+        <p:nvSpPr>
+          <p:cNvPr id="8" name="TextBox 7"/>
+          <p:cNvSpPr txBox="1"/>
+          <p:nvPr/>
+        </p:nvSpPr>
+        <p:spPr>
+          <a:xfrm>
+            <a:off x="3840480" y="2267712"/>
+            <a:ext cx="7680960" cy="502920"/>
+          </a:xfrm>
+          <a:prstGeom prst="rect">
+            <a:avLst/>
+          </a:prstGeom>
+          <a:noFill/>
+        </p:spPr>
+        <p:txBody>
+          <a:bodyPr wrap="square">
+            <a:spAutoFit/>
+          </a:bodyPr>
+          <a:lstStyle/>
+          <a:p>
+            <a:pPr>
+              <a:defRPr sz="1700" b="0">
+                <a:solidFill>
+                  <a:srgbClr val="4A4A4A"/>
+                </a:solidFill>
+              </a:defRPr>
+            </a:pPr>
+            <a:r>
+              <a:t>Tests whether the belief tracks a strategy change mid-episode.</a:t>
+            </a:r>
+          </a:p>
+        </p:txBody>
+      </p:sp>
+      <p:sp>
+        <p:nvSpPr>
+          <p:cNvPr id="9" name="TextBox 8"/>
+          <p:cNvSpPr txBox="1"/>
+          <p:nvPr/>
+        </p:nvSpPr>
+        <p:spPr>
+          <a:xfrm>
+            <a:off x="822960" y="2980944"/>
+            <a:ext cx="2834640" cy="411480"/>
+          </a:xfrm>
+          <a:prstGeom prst="rect">
+            <a:avLst/>
+          </a:prstGeom>
+          <a:noFill/>
+        </p:spPr>
+        <p:txBody>
+          <a:bodyPr wrap="square">
+            <a:spAutoFit/>
+          </a:bodyPr>
+          <a:lstStyle/>
+          <a:p>
+            <a:pPr>
+              <a:defRPr sz="1800" b="1">
+                <a:solidFill>
+                  <a:srgbClr val="171717"/>
+                </a:solidFill>
+              </a:defRPr>
+            </a:pPr>
+            <a:r>
+              <a:t>HOP baseline</a:t>
+            </a:r>
+          </a:p>
+        </p:txBody>
+      </p:sp>
+      <p:sp>
+        <p:nvSpPr>
+          <p:cNvPr id="10" name="TextBox 9"/>
+          <p:cNvSpPr txBox="1"/>
+          <p:nvPr/>
+        </p:nvSpPr>
+        <p:spPr>
+          <a:xfrm>
+            <a:off x="3840480" y="2980944"/>
+            <a:ext cx="7680960" cy="502920"/>
+          </a:xfrm>
+          <a:prstGeom prst="rect">
+            <a:avLst/>
+          </a:prstGeom>
+          <a:noFill/>
+        </p:spPr>
+        <p:txBody>
+          <a:bodyPr wrap="square">
+            <a:spAutoFit/>
+          </a:bodyPr>
+          <a:lstStyle/>
+          <a:p>
+            <a:pPr>
+              <a:defRPr sz="1700" b="0">
+                <a:solidFill>
+                  <a:srgbClr val="4A4A4A"/>
+                </a:solidFill>
+              </a:defRPr>
+            </a:pPr>
+            <a:r>
+              <a:t>Checks the closest belief-search comparator.</a:t>
+            </a:r>
+          </a:p>
+        </p:txBody>
+      </p:sp>
+      <p:sp>
+        <p:nvSpPr>
+          <p:cNvPr id="11" name="TextBox 10"/>
+          <p:cNvSpPr txBox="1"/>
+          <p:nvPr/>
+        </p:nvSpPr>
+        <p:spPr>
+          <a:xfrm>
+            <a:off x="822960" y="3694176"/>
+            <a:ext cx="2834640" cy="411480"/>
+          </a:xfrm>
+          <a:prstGeom prst="rect">
+            <a:avLst/>
+          </a:prstGeom>
+          <a:noFill/>
+        </p:spPr>
+        <p:txBody>
+          <a:bodyPr wrap="square">
+            <a:spAutoFit/>
+          </a:bodyPr>
+          <a:lstStyle/>
+          <a:p>
+            <a:pPr>
+              <a:defRPr sz="1800" b="1">
+                <a:solidFill>
+                  <a:srgbClr val="171717"/>
+                </a:solidFill>
+              </a:defRPr>
+            </a:pPr>
+            <a:r>
+              <a:t>Snake placement</a:t>
+            </a:r>
+          </a:p>
+        </p:txBody>
+      </p:sp>
+      <p:sp>
+        <p:nvSpPr>
+          <p:cNvPr id="12" name="TextBox 11"/>
+          <p:cNvSpPr txBox="1"/>
+          <p:nvPr/>
+        </p:nvSpPr>
+        <p:spPr>
+          <a:xfrm>
+            <a:off x="3840480" y="3694176"/>
+            <a:ext cx="7680960" cy="502920"/>
+          </a:xfrm>
+          <a:prstGeom prst="rect">
+            <a:avLst/>
+          </a:prstGeom>
+          <a:noFill/>
+        </p:spPr>
+        <p:txBody>
+          <a:bodyPr wrap="square">
+            <a:spAutoFit/>
+          </a:bodyPr>
+          <a:lstStyle/>
+          <a:p>
+            <a:pPr>
+              <a:defRPr sz="1700" b="0">
+                <a:solidFill>
+                  <a:srgbClr val="4A4A4A"/>
+                </a:solidFill>
+              </a:defRPr>
+            </a:pPr>
+            <a:r>
+              <a:t>A genuinely distinct behaviour class, so clusters can exist.</a:t>
+            </a:r>
+          </a:p>
+        </p:txBody>
+      </p:sp>
+      <p:sp>
+        <p:nvSpPr>
+          <p:cNvPr id="13" name="TextBox 12"/>
+          <p:cNvSpPr txBox="1"/>
+          <p:nvPr/>
+        </p:nvSpPr>
+        <p:spPr>
+          <a:xfrm>
+            <a:off x="822960" y="4407408"/>
+            <a:ext cx="2834640" cy="411480"/>
+          </a:xfrm>
+          <a:prstGeom prst="rect">
+            <a:avLst/>
+          </a:prstGeom>
+          <a:noFill/>
+        </p:spPr>
+        <p:txBody>
+          <a:bodyPr wrap="square">
+            <a:spAutoFit/>
+          </a:bodyPr>
+          <a:lstStyle/>
+          <a:p>
+            <a:pPr>
+              <a:defRPr sz="1800" b="1">
+                <a:solidFill>
+                  <a:srgbClr val="171717"/>
+                </a:solidFill>
+              </a:defRPr>
+            </a:pPr>
+            <a:r>
+              <a:t>Raw artifact archive</a:t>
+            </a:r>
+          </a:p>
+        </p:txBody>
+      </p:sp>
+      <p:sp>
+        <p:nvSpPr>
+          <p:cNvPr id="14" name="TextBox 13"/>
+          <p:cNvSpPr txBox="1"/>
+          <p:nvPr/>
+        </p:nvSpPr>
+        <p:spPr>
+          <a:xfrm>
+            <a:off x="3840480" y="4407408"/>
+            <a:ext cx="7680960" cy="502920"/>
+          </a:xfrm>
+          <a:prstGeom prst="rect">
+            <a:avLst/>
+          </a:prstGeom>
+          <a:noFill/>
+        </p:spPr>
+        <p:txBody>
+          <a:bodyPr wrap="square">
+            <a:spAutoFit/>
+          </a:bodyPr>
+          <a:lstStyle/>
+          <a:p>
+            <a:pPr>
+              <a:defRPr sz="1700" b="0">
+                <a:solidFill>
+                  <a:srgbClr val="4A4A4A"/>
+                </a:solidFill>
+              </a:defRPr>
+            </a:pPr>
+            <a:r>
+              <a:t>Pins checkpoints, logs, and metrics to a release DOI.</a:t>
+            </a:r>
+          </a:p>
+        </p:txBody>
+      </p:sp>
+      <p:sp>
+        <p:nvSpPr>
+          <p:cNvPr id="15" name="TextBox 14"/>
+          <p:cNvSpPr txBox="1"/>
+          <p:nvPr/>
+        </p:nvSpPr>
+        <p:spPr>
+          <a:xfrm>
+            <a:off x="822960" y="5349240"/>
+            <a:ext cx="10607040" cy="548640"/>
+          </a:xfrm>
+          <a:prstGeom prst="rect">
+            <a:avLst/>
+          </a:prstGeom>
+          <a:noFill/>
+        </p:spPr>
+        <p:txBody>
+          <a:bodyPr wrap="square">
+            <a:spAutoFit/>
+          </a:bodyPr>
+          <a:lstStyle/>
+          <a:p>
+            <a:pPr>
+              <a:defRPr sz="1800" b="1">
+                <a:solidFill>
+                  <a:srgbClr val="171717"/>
+                </a:solidFill>
+              </a:defRPr>
+            </a:pPr>
+            <a:r>
+              <a:t>End with a concrete ask: accept the controlled result, then fund the baseline and switching-opponent run.</a:t>
             </a:r>
           </a:p>
         </p:txBody>

</xml_diff>